<commit_message>
Deck: correct the semantic-cache claims to match what was measured
Two slides asserted that a reworded question hits the same cache entry. On
this deployment it does not, and the distractor outscores it:

  identical repeat                 1.0000
  two-word-different question      0.9431
  true paraphrase                  0.8555

Replaced with the measurement and the conclusion it supports -- a similarity
threshold is a precision/recall dial you set against your own prompts, not a
meaning detector. The use-case table now quotes the real numbers from the
smoke test (750 ms against 6.9 s) rather than a claim about paraphrases.

Also softened "robust to paraphrase" on the signals slide for the same reason.

Co-Authored-By: Claude Opus 5 <noreply@anthropic.com>
</commit_message>
<xml_diff>
--- a/docs/presentation/vLLM-Semantic-Router.pptx
+++ b/docs/presentation/vLLM-Semantic-Router.pptx
@@ -9467,7 +9467,7 @@
                 </a:solidFill>
                 <a:latin typeface="Helvetica Neue"/>
               </a:rPr>
-              <a:t>Embedding similarity, not a hash. A reworded question hits the same cache entry. Thresholds are per-route — strict where a near-miss would be costly.</a:t>
+              <a:t>Embedding similarity, not a hash — but measure before you trust it. Here an identical repeat scores 1.0000, a two-word-different question 0.9431, and a true paraphrase only 0.8555. The wrong question outscores the paraphrase, so the threshold is a precision/recall dial, not a meaning detector.</a:t>
             </a:r>
           </a:p>
         </p:txBody>
@@ -14950,7 +14950,7 @@
                           </a:solidFill>
                           <a:latin typeface="Helvetica Neue"/>
                         </a:rPr>
-                        <a:t>A reworded question hits the cache. Pinning a model opts out of all of it.</a:t>
+                        <a:t>A repeat returns in 750 ms instead of 6.9 s. A near-miss is correctly refused. Pinning a model opts out of all of it.</a:t>
                       </a:r>
                     </a:p>
                   </a:txBody>
@@ -19265,7 +19265,7 @@
                 </a:solidFill>
                 <a:latin typeface="Helvetica Neue"/>
               </a:rPr>
-              <a:t>Embedding similarity and classifier models detecting intent, domain, complexity, PII and jailbreak patterns. Robust to paraphrase; probabilistic.</a:t>
+              <a:t>Embedding similarity and classifier models detecting intent, domain, complexity, PII and jailbreak patterns. More robust than keywords; probabilistic, and worth measuring on your own prompts.</a:t>
             </a:r>
           </a:p>
         </p:txBody>

</xml_diff>

<commit_message>
Notes at 14 and readable: paragraphs, taller panel, 14pt in PowerPoint
The notes went from short hints to full spoken scripts, and the panel was
still styled for hints -- 16px, one unbroken wall of text, 32vh -- so the
longer ones scrolled and were hard to find your place in mid-sentence.

HTML deck: 14px with 1.5 leading, panel raised to 38vh, and blank lines in the
script now render as real paragraphs rather than collapsing. The stage scale
accounts for the taller panel so the slide is never clipped behind it. Verified
against slide 11, the longest script at 194 words -- it fits with room to spare.

PowerPoint: notes were inheriting the notes-master default, which is too small
to read at a lectern. Now explicitly 14pt with 6pt paragraph spacing, asserted
across all 21 slides.

Co-Authored-By: Claude Opus 5 <noreply@anthropic.com>
</commit_message>
<xml_diff>
--- a/docs/presentation/vLLM-Semantic-Router.pptx
+++ b/docs/presentation/vLLM-Semantic-Router.pptx
@@ -521,19 +521,49 @@
           <a:bodyPr/>
           <a:lstStyle/>
           <a:p>
-            <a:r>
+            <a:pPr>
+              <a:spcAft>
+                <a:spcPts val="600"/>
+              </a:spcAft>
+            </a:pPr>
+            <a:r>
+              <a:rPr sz="1400"/>
               <a:t>Thanks for coming. The next twenty minutes are slides, and then ten minutes of this running live on a cluster — not a recording.</a:t>
             </a:r>
           </a:p>
-          <a:p/>
-          <a:p>
-            <a:r>
+          <a:p>
+            <a:pPr>
+              <a:spcAft>
+                <a:spcPts val="600"/>
+              </a:spcAft>
+            </a:pPr>
+          </a:p>
+          <a:p>
+            <a:pPr>
+              <a:spcAft>
+                <a:spcPts val="600"/>
+              </a:spcAft>
+            </a:pPr>
+            <a:r>
+              <a:rPr sz="1400"/>
               <a:t>I want to start with a problem rather than a product, because the product only really makes sense once the problem is obvious. So give me five minutes before I tell you what this thing is.</a:t>
             </a:r>
           </a:p>
-          <a:p/>
-          <a:p>
-            <a:r>
+          <a:p>
+            <a:pPr>
+              <a:spcAft>
+                <a:spcPts val="600"/>
+              </a:spcAft>
+            </a:pPr>
+          </a:p>
+          <a:p>
+            <a:pPr>
+              <a:spcAft>
+                <a:spcPts val="600"/>
+              </a:spcAft>
+            </a:pPr>
+            <a:r>
+              <a:rPr sz="1400"/>
               <a:t>Quick show of hands — who is running more than one model in production today? [pause] Right. And who decides which one handles a given request? That's the talk.</a:t>
             </a:r>
           </a:p>
@@ -603,37 +633,103 @@
           <a:bodyPr/>
           <a:lstStyle/>
           <a:p>
-            <a:r>
+            <a:pPr>
+              <a:spcAft>
+                <a:spcPts val="600"/>
+              </a:spcAft>
+            </a:pPr>
+            <a:r>
+              <a:rPr sz="1400"/>
               <a:t>Signals are facts extracted from the request. And the key thing is that two very different kinds of detection sit side by side.</a:t>
             </a:r>
           </a:p>
-          <a:p/>
-          <a:p>
-            <a:r>
+          <a:p>
+            <a:pPr>
+              <a:spcAft>
+                <a:spcPts val="600"/>
+              </a:spcAft>
+            </a:pPr>
+          </a:p>
+          <a:p>
+            <a:pPr>
+              <a:spcAft>
+                <a:spcPts val="600"/>
+              </a:spcAft>
+            </a:pPr>
+            <a:r>
+              <a:rPr sz="1400"/>
               <a:t>Deterministic signals are keyword lists and metadata predicates. They're cheap, they're auditable, you can explain them to a compliance team in one sentence — and they're trivially evaded.</a:t>
             </a:r>
           </a:p>
-          <a:p/>
-          <a:p>
-            <a:r>
+          <a:p>
+            <a:pPr>
+              <a:spcAft>
+                <a:spcPts val="600"/>
+              </a:spcAft>
+            </a:pPr>
+          </a:p>
+          <a:p>
+            <a:pPr>
+              <a:spcAft>
+                <a:spcPts val="600"/>
+              </a:spcAft>
+            </a:pPr>
+            <a:r>
+              <a:rPr sz="1400"/>
               <a:t>Learned signals are small fine-tuned classifiers. Domain classification across fourteen categories, a jailbreak detector, and a PII model that tags individual words across seventeen entity types. Plus an embedding model used for routing and for the cache. You'll see both kinds in the demo, and you'll see exactly why you want both.</a:t>
             </a:r>
           </a:p>
-          <a:p/>
-          <a:p>
-            <a:r>
+          <a:p>
+            <a:pPr>
+              <a:spcAft>
+                <a:spcPts val="600"/>
+              </a:spcAft>
+            </a:pPr>
+          </a:p>
+          <a:p>
+            <a:pPr>
+              <a:spcAft>
+                <a:spcPts val="600"/>
+              </a:spcAft>
+            </a:pPr>
+            <a:r>
+              <a:rPr sz="1400"/>
               <a:t>One naming note, because two names circulate: Vela is the project's branding for its mmBERT encoders. Same models.</a:t>
             </a:r>
           </a:p>
-          <a:p/>
-          <a:p>
-            <a:r>
+          <a:p>
+            <a:pPr>
+              <a:spcAft>
+                <a:spcPts val="600"/>
+              </a:spcAft>
+            </a:pPr>
+          </a:p>
+          <a:p>
+            <a:pPr>
+              <a:spcAft>
+                <a:spcPts val="600"/>
+              </a:spcAft>
+            </a:pPr>
+            <a:r>
+              <a:rPr sz="1400"/>
               <a:t>And all of these are just a model ID in a config file. Point it at your own fine-tune and it loads yours instead — the project took their own complexity classifier from eighty percent to ninety-eight that way.</a:t>
             </a:r>
           </a:p>
-          <a:p/>
-          <a:p>
-            <a:r>
+          <a:p>
+            <a:pPr>
+              <a:spcAft>
+                <a:spcPts val="600"/>
+              </a:spcAft>
+            </a:pPr>
+          </a:p>
+          <a:p>
+            <a:pPr>
+              <a:spcAft>
+                <a:spcPts val="600"/>
+              </a:spcAft>
+            </a:pPr>
+            <a:r>
+              <a:rPr sz="1400"/>
               <a:t>Last thing, and it's a design discipline that matters: signals describe facts. They never choose the backend. That's the next stage's job.</a:t>
             </a:r>
           </a:p>
@@ -703,31 +799,85 @@
           <a:bodyPr/>
           <a:lstStyle/>
           <a:p>
-            <a:r>
+            <a:pPr>
+              <a:spcAft>
+                <a:spcPts val="600"/>
+              </a:spcAft>
+            </a:pPr>
+            <a:r>
+              <a:rPr sz="1400"/>
               <a:t>Decisions are where your policy actually lives. Boolean rules, arbitrarily nested, over those signals. Priority resolves conflicts — highest matching rule wins.</a:t>
             </a:r>
           </a:p>
-          <a:p/>
-          <a:p>
-            <a:r>
+          <a:p>
+            <a:pPr>
+              <a:spcAft>
+                <a:spcPts val="600"/>
+              </a:spcAft>
+            </a:pPr>
+          </a:p>
+          <a:p>
+            <a:pPr>
+              <a:spcAft>
+                <a:spcPts val="600"/>
+              </a:spcAft>
+            </a:pPr>
+            <a:r>
+              <a:rPr sz="1400"/>
               <a:t>Our ladder, top to bottom, goes like this. Guardrails first: PII, unsafe content, jailbreak. Then policy overrides — things like an urgent security review, which should get the best model regardless of what anything else thinks. Then difficulty. Then intent. And anything that matches nothing at all falls through to the small model.</a:t>
             </a:r>
           </a:p>
-          <a:p/>
-          <a:p>
-            <a:r>
+          <a:p>
+            <a:pPr>
+              <a:spcAft>
+                <a:spcPts val="600"/>
+              </a:spcAft>
+            </a:pPr>
+          </a:p>
+          <a:p>
+            <a:pPr>
+              <a:spcAft>
+                <a:spcPts val="600"/>
+              </a:spcAft>
+            </a:pPr>
+            <a:r>
+              <a:rPr sz="1400"/>
               <a:t>That ordering is deliberate: guardrails sit far above routing, so no cost optimisation can ever outrank a safety rule. You can't accidentally save money by skipping a check.</a:t>
             </a:r>
           </a:p>
-          <a:p/>
-          <a:p>
-            <a:r>
+          <a:p>
+            <a:pPr>
+              <a:spcAft>
+                <a:spcPts val="600"/>
+              </a:spcAft>
+            </a:pPr>
+          </a:p>
+          <a:p>
+            <a:pPr>
+              <a:spcAft>
+                <a:spcPts val="600"/>
+              </a:spcAft>
+            </a:pPr>
+            <a:r>
+              <a:rPr sz="1400"/>
               <a:t>Middle card is a rule of thumb worth stealing: hard requirements decide eligibility before any optimiser compares cost or latency. Authorization, local-only processing, context capacity. A backend that can't legally serve the request shouldn't be in the race at all.</a:t>
             </a:r>
           </a:p>
-          <a:p/>
-          <a:p>
-            <a:r>
+          <a:p>
+            <a:pPr>
+              <a:spcAft>
+                <a:spcPts val="600"/>
+              </a:spcAft>
+            </a:pPr>
+          </a:p>
+          <a:p>
+            <a:pPr>
+              <a:spcAft>
+                <a:spcPts val="600"/>
+              </a:spcAft>
+            </a:pPr>
+            <a:r>
+              <a:rPr sz="1400"/>
               <a:t>And the third one is the governance story, which is much stronger than "we block PII". The PII signal only reports that it found something. The decision chooses what to do about it — block, reroute to a local-only model, redact, or just log it. Same detector, different policy per team.</a:t>
             </a:r>
           </a:p>
@@ -797,31 +947,85 @@
           <a:bodyPr/>
           <a:lstStyle/>
           <a:p>
-            <a:r>
+            <a:pPr>
+              <a:spcAft>
+                <a:spcPts val="600"/>
+              </a:spcAft>
+            </a:pPr>
+            <a:r>
+              <a:rPr sz="1400"/>
               <a:t>The two stages everyone skips.</a:t>
             </a:r>
           </a:p>
-          <a:p/>
-          <a:p>
-            <a:r>
+          <a:p>
+            <a:pPr>
+              <a:spcAft>
+                <a:spcPts val="600"/>
+              </a:spcAft>
+            </a:pPr>
+          </a:p>
+          <a:p>
+            <a:pPr>
+              <a:spcAft>
+                <a:spcPts val="600"/>
+              </a:spcAft>
+            </a:pPr>
+            <a:r>
+              <a:rPr sz="1400"/>
               <a:t>Projections stop your decision list collapsing into a pile of overlapping conditions. Define a difficulty score once, then reference it from ten different rules instead of re-deriving it in each.</a:t>
             </a:r>
           </a:p>
-          <a:p/>
-          <a:p>
-            <a:r>
+          <a:p>
+            <a:pPr>
+              <a:spcAft>
+                <a:spcPts val="600"/>
+              </a:spcAft>
+            </a:pPr>
+          </a:p>
+          <a:p>
+            <a:pPr>
+              <a:spcAft>
+                <a:spcPts val="600"/>
+              </a:spcAft>
+            </a:pPr>
+            <a:r>
+              <a:rPr sz="1400"/>
               <a:t>Algorithms are the more interesting half. Selection algorithms pick one model — fixed order, semantic fit, measured latency, or learning from feedback over time.</a:t>
             </a:r>
           </a:p>
-          <a:p/>
-          <a:p>
-            <a:r>
+          <a:p>
+            <a:pPr>
+              <a:spcAft>
+                <a:spcPts val="600"/>
+              </a:spcAft>
+            </a:pPr>
+          </a:p>
+          <a:p>
+            <a:pPr>
+              <a:spcAft>
+                <a:spcPts val="600"/>
+              </a:spcAft>
+            </a:pPr>
+            <a:r>
+              <a:rPr sz="1400"/>
               <a:t>But loopers coordinate several models for a single request. Cascade escalates cheap-to-expensive when confidence is low. Fusion asks several and synthesises. Workflow runs planner, thinker, worker, verifier as separate roles. That's not routing any more — that's orchestration.</a:t>
             </a:r>
           </a:p>
-          <a:p/>
-          <a:p>
-            <a:r>
+          <a:p>
+            <a:pPr>
+              <a:spcAft>
+                <a:spcPts val="600"/>
+              </a:spcAft>
+            </a:pPr>
+          </a:p>
+          <a:p>
+            <a:pPr>
+              <a:spcAft>
+                <a:spcPts val="600"/>
+              </a:spcAft>
+            </a:pPr>
+            <a:r>
+              <a:rPr sz="1400"/>
               <a:t>I'll be straight: my demo uses the simplest selection algorithm and no loopers at all. But that's the ceiling of what this model can do, and it's worth knowing it's there.</a:t>
             </a:r>
           </a:p>
@@ -891,25 +1095,67 @@
           <a:bodyPr/>
           <a:lstStyle/>
           <a:p>
-            <a:r>
+            <a:pPr>
+              <a:spcAft>
+                <a:spcPts val="600"/>
+              </a:spcAft>
+            </a:pPr>
+            <a:r>
+              <a:rPr sz="1400"/>
               <a:t>One more concept and then I'll show you it running.</a:t>
             </a:r>
           </a:p>
-          <a:p/>
-          <a:p>
-            <a:r>
+          <a:p>
+            <a:pPr>
+              <a:spcAft>
+                <a:spcPts val="600"/>
+              </a:spcAft>
+            </a:pPr>
+          </a:p>
+          <a:p>
+            <a:pPr>
+              <a:spcAft>
+                <a:spcPts val="600"/>
+              </a:spcAft>
+            </a:pPr>
+            <a:r>
+              <a:rPr sz="1400"/>
               <a:t>A recipe is a complete, self-contained policy — its own signals, decisions, algorithms, plugins, even its own cache namespace. And an entrypoint decides which recipe handles a given request.</a:t>
             </a:r>
           </a:p>
-          <a:p/>
-          <a:p>
-            <a:r>
+          <a:p>
+            <a:pPr>
+              <a:spcAft>
+                <a:spcPts val="600"/>
+              </a:spcAft>
+            </a:pPr>
+          </a:p>
+          <a:p>
+            <a:pPr>
+              <a:spcAft>
+                <a:spcPts val="600"/>
+              </a:spcAft>
+            </a:pPr>
+            <a:r>
+              <a:rPr sz="1400"/>
               <a:t>The practical bit is the middle column. These ship as virtual model names. So a team adopts an entire routing policy by changing one string in their client — point at mom-v1-lite if they care about cost, mom-v1-ultra if they care about accuracy — and they can tune a bespoke recipe later when they know what they want.</a:t>
             </a:r>
           </a:p>
-          <a:p/>
-          <a:p>
-            <a:r>
+          <a:p>
+            <a:pPr>
+              <a:spcAft>
+                <a:spcPts val="600"/>
+              </a:spcAft>
+            </a:pPr>
+          </a:p>
+          <a:p>
+            <a:pPr>
+              <a:spcAft>
+                <a:spcPts val="600"/>
+              </a:spcAft>
+            </a:pPr>
+            <a:r>
+              <a:rPr sz="1400"/>
               <a:t>And this answers the question every platform team asks me: can I run different policies for different consumers without standing up a second router? Yes. Two teams, two risk appetites, one platform, and nobody has to agree on a single global threshold.</a:t>
             </a:r>
           </a:p>
@@ -979,31 +1225,85 @@
           <a:bodyPr/>
           <a:lstStyle/>
           <a:p>
-            <a:r>
+            <a:pPr>
+              <a:spcAft>
+                <a:spcPts val="600"/>
+              </a:spcAft>
+            </a:pPr>
+            <a:r>
+              <a:rPr sz="1400"/>
               <a:t>Let me give you some numbers, and let me be precise about where they come from.</a:t>
             </a:r>
           </a:p>
-          <a:p/>
-          <a:p>
-            <a:r>
+          <a:p>
+            <a:pPr>
+              <a:spcAft>
+                <a:spcPts val="600"/>
+              </a:spcAft>
+            </a:pPr>
+          </a:p>
+          <a:p>
+            <a:pPr>
+              <a:spcAft>
+                <a:spcPts val="600"/>
+              </a:spcAft>
+            </a:pPr>
+            <a:r>
+              <a:rPr sz="1400"/>
               <a:t>These are the project's own in-house benchmarks. They're not independent, they haven't been reproduced by a third party, and I did not measure them. I'm showing them because they're the best public figures available, not because I can vouch for them.</a:t>
             </a:r>
           </a:p>
-          <a:p/>
-          <a:p>
-            <a:r>
+          <a:p>
+            <a:pPr>
+              <a:spcAft>
+                <a:spcPts val="600"/>
+              </a:spcAft>
+            </a:pPr>
+          </a:p>
+          <a:p>
+            <a:pPr>
+              <a:spcAft>
+                <a:spcPts val="600"/>
+              </a:spcAft>
+            </a:pPr>
+            <a:r>
+              <a:rPr sz="1400"/>
               <a:t>Eighty-six percent of traffic kept on local models. Forty milliseconds P50 routing latency — and I'd flag that one specifically, because it's an internal measurement on their hardware. If you benchmark this yourself on a shared CPU node you will not see forty milliseconds, and that's not a defect.</a:t>
             </a:r>
           </a:p>
-          <a:p/>
-          <a:p>
-            <a:r>
+          <a:p>
+            <a:pPr>
+              <a:spcAft>
+                <a:spcPts val="600"/>
+              </a:spcAft>
+            </a:pPr>
+          </a:p>
+          <a:p>
+            <a:pPr>
+              <a:spcAft>
+                <a:spcPts val="600"/>
+              </a:spcAft>
+            </a:pPr>
+            <a:r>
+              <a:rPr sz="1400"/>
               <a:t>The row I'd actually pay attention to is the fine-tuning one. They took complexity classification from eighty percent to ninety-eight and a half. Twenty-three million parameters, under two hours on CPU, and it drops in as a model swap — no architecture change, no redeployment. Their stated lesson was that the loss function mattered more than the volume of training data.</a:t>
             </a:r>
           </a:p>
-          <a:p/>
-          <a:p>
-            <a:r>
+          <a:p>
+            <a:pPr>
+              <a:spcAft>
+                <a:spcPts val="600"/>
+              </a:spcAft>
+            </a:pPr>
+          </a:p>
+          <a:p>
+            <a:pPr>
+              <a:spcAft>
+                <a:spcPts val="600"/>
+              </a:spcAft>
+            </a:pPr>
+            <a:r>
+              <a:rPr sz="1400"/>
               <a:t>Re-validate all of this against your own workload before you quote it to anyone.</a:t>
             </a:r>
           </a:p>
@@ -1073,19 +1373,49 @@
           <a:bodyPr/>
           <a:lstStyle/>
           <a:p>
-            <a:r>
+            <a:pPr>
+              <a:spcAft>
+                <a:spcPts val="600"/>
+              </a:spcAft>
+            </a:pPr>
+            <a:r>
+              <a:rPr sz="1400"/>
               <a:t>[This slide is hidden and is not in the running order.]</a:t>
             </a:r>
           </a:p>
-          <a:p/>
-          <a:p>
-            <a:r>
+          <a:p>
+            <a:pPr>
+              <a:spcAft>
+                <a:spcPts val="600"/>
+              </a:spcAft>
+            </a:pPr>
+          </a:p>
+          <a:p>
+            <a:pPr>
+              <a:spcAft>
+                <a:spcPts val="600"/>
+              </a:spcAft>
+            </a:pPr>
+            <a:r>
+              <a:rPr sz="1400"/>
               <a:t>It's kept as backup in case someone asks whether any of this was actually run, or challenges the numbers on the previous slide. It holds our own measurements from this cluster: 192 ms routing overhead, roughly 900 ms guardrail blocks with no GPU involved, 6.9 seconds down to 0.75 on a cache hit, the cache-precision figures, the PII over-blocking on dates and place names, and the 10.3 GB classifier footprint.</a:t>
             </a:r>
           </a:p>
-          <a:p/>
-          <a:p>
-            <a:r>
+          <a:p>
+            <a:pPr>
+              <a:spcAft>
+                <a:spcPts val="600"/>
+              </a:spcAft>
+            </a:pPr>
+          </a:p>
+          <a:p>
+            <a:pPr>
+              <a:spcAft>
+                <a:spcPts val="600"/>
+              </a:spcAft>
+            </a:pPr>
+            <a:r>
+              <a:rPr sz="1400"/>
               <a:t>To bring it back into the deck, remove "hidden": true from deck.js and rebuild.</a:t>
             </a:r>
           </a:p>
@@ -1155,31 +1485,85 @@
           <a:bodyPr/>
           <a:lstStyle/>
           <a:p>
-            <a:r>
+            <a:pPr>
+              <a:spcAft>
+                <a:spcPts val="600"/>
+              </a:spcAft>
+            </a:pPr>
+            <a:r>
+              <a:rPr sz="1400"/>
               <a:t>Before the demo, one honest caveat. Routing is the first line of defence. It cannot be the only one.</a:t>
             </a:r>
           </a:p>
-          <a:p/>
-          <a:p>
-            <a:r>
+          <a:p>
+            <a:pPr>
+              <a:spcAft>
+                <a:spcPts val="600"/>
+              </a:spcAft>
+            </a:pPr>
+          </a:p>
+          <a:p>
+            <a:pPr>
+              <a:spcAft>
+                <a:spcPts val="600"/>
+              </a:spcAft>
+            </a:pPr>
+            <a:r>
+              <a:rPr sz="1400"/>
               <a:t>Classification is probabilistic. It will be right most of the time, and you need to plan for the tail rather than pretend there isn't one.</a:t>
             </a:r>
           </a:p>
-          <a:p/>
-          <a:p>
-            <a:r>
+          <a:p>
+            <a:pPr>
+              <a:spcAft>
+                <a:spcPts val="600"/>
+              </a:spcAft>
+            </a:pPr>
+          </a:p>
+          <a:p>
+            <a:pPr>
+              <a:spcAft>
+                <a:spcPts val="600"/>
+              </a:spcAft>
+            </a:pPr>
+            <a:r>
+              <a:rPr sz="1400"/>
               <a:t>So: routing places most requests correctly before any GPU work happens. Evaluation and guardrails catch what it misclassifies. And egress controls filter what comes back — because a local model can still emit sensitive data, and routing only ever saw the question, never the answer.</a:t>
             </a:r>
           </a:p>
-          <a:p/>
-          <a:p>
-            <a:r>
+          <a:p>
+            <a:pPr>
+              <a:spcAft>
+                <a:spcPts val="600"/>
+              </a:spcAft>
+            </a:pPr>
+          </a:p>
+          <a:p>
+            <a:pPr>
+              <a:spcAft>
+                <a:spcPts val="600"/>
+              </a:spcAft>
+            </a:pPr>
+            <a:r>
+              <a:rPr sz="1400"/>
               <a:t>In practice that becomes a data policy: account records and personal data never leave the building and get logged when they're used. Internal material can go to a cloud model only if something inspects it on the way out. Public questions go anywhere.</a:t>
             </a:r>
           </a:p>
-          <a:p/>
-          <a:p>
-            <a:r>
+          <a:p>
+            <a:pPr>
+              <a:spcAft>
+                <a:spcPts val="600"/>
+              </a:spcAft>
+            </a:pPr>
+          </a:p>
+          <a:p>
+            <a:pPr>
+              <a:spcAft>
+                <a:spcPts val="600"/>
+              </a:spcAft>
+            </a:pPr>
+            <a:r>
+              <a:rPr sz="1400"/>
               <a:t>What I'm about to show you implements the first layer and part of the second. No egress controls at all. I'd rather tell you that than have you assume otherwise.</a:t>
             </a:r>
           </a:p>
@@ -1249,25 +1633,67 @@
           <a:bodyPr/>
           <a:lstStyle/>
           <a:p>
-            <a:r>
+            <a:pPr>
+              <a:spcAft>
+                <a:spcPts val="600"/>
+              </a:spcAft>
+            </a:pPr>
+            <a:r>
+              <a:rPr sz="1400"/>
               <a:t>One last thing on where this matters most, and it's agents.</a:t>
             </a:r>
           </a:p>
-          <a:p/>
-          <a:p>
-            <a:r>
+          <a:p>
+            <a:pPr>
+              <a:spcAft>
+                <a:spcPts val="600"/>
+              </a:spcAft>
+            </a:pPr>
+          </a:p>
+          <a:p>
+            <a:pPr>
+              <a:spcAft>
+                <a:spcPts val="600"/>
+              </a:spcAft>
+            </a:pPr>
+            <a:r>
+              <a:rPr sz="1400"/>
               <a:t>An agent isn't one request — it's a loop. A single task generates ten to fifty model calls. Without routing, every one of those hits the same expensive model.</a:t>
             </a:r>
           </a:p>
-          <a:p/>
-          <a:p>
-            <a:r>
+          <a:p>
+            <a:pPr>
+              <a:spcAft>
+                <a:spcPts val="600"/>
+              </a:spcAft>
+            </a:pPr>
+          </a:p>
+          <a:p>
+            <a:pPr>
+              <a:spcAft>
+                <a:spcPts val="600"/>
+              </a:spcAft>
+            </a:pPr>
+            <a:r>
+              <a:rPr sz="1400"/>
               <a:t>That's the Uber slide again, just at a different scale. The multiplier is what turns a manageable bill into an unmanageable one.</a:t>
             </a:r>
           </a:p>
-          <a:p/>
-          <a:p>
-            <a:r>
+          <a:p>
+            <a:pPr>
+              <a:spcAft>
+                <a:spcPts val="600"/>
+              </a:spcAft>
+            </a:pPr>
+          </a:p>
+          <a:p>
+            <a:pPr>
+              <a:spcAft>
+                <a:spcPts val="600"/>
+              </a:spcAft>
+            </a:pPr>
+            <a:r>
+              <a:rPr sz="1400"/>
               <a:t>And the safety angle is underrated: every call in that loop passes the same classification. One policy covers an agent you didn't write and can't inspect — because enforcement is at the gateway, not inside the agent.</a:t>
             </a:r>
           </a:p>
@@ -1337,37 +1763,103 @@
           <a:bodyPr/>
           <a:lstStyle/>
           <a:p>
-            <a:r>
+            <a:pPr>
+              <a:spcAft>
+                <a:spcPts val="600"/>
+              </a:spcAft>
+            </a:pPr>
+            <a:r>
+              <a:rPr sz="1400"/>
               <a:t>Last slide, and it's the question I get asked most: how does this relate to llm-d?</a:t>
             </a:r>
           </a:p>
-          <a:p/>
-          <a:p>
-            <a:r>
+          <a:p>
+            <a:pPr>
+              <a:spcAft>
+                <a:spcPts val="600"/>
+              </a:spcAft>
+            </a:pPr>
+          </a:p>
+          <a:p>
+            <a:pPr>
+              <a:spcAft>
+                <a:spcPts val="600"/>
+              </a:spcAft>
+            </a:pPr>
+            <a:r>
+              <a:rPr sz="1400"/>
               <a:t>They're not alternatives. They answer different questions.</a:t>
             </a:r>
           </a:p>
-          <a:p/>
-          <a:p>
-            <a:r>
+          <a:p>
+            <a:pPr>
+              <a:spcAft>
+                <a:spcPts val="600"/>
+              </a:spcAft>
+            </a:pPr>
+          </a:p>
+          <a:p>
+            <a:pPr>
+              <a:spcAft>
+                <a:spcPts val="600"/>
+              </a:spcAft>
+            </a:pPr>
+            <a:r>
+              <a:rPr sz="1400"/>
               <a:t>The semantic router asks what model should handle this, and routes between entirely different base models based on semantics and policy. llm-d asks where this should execute, and routes between replicas of the same model based on load and KV-cache locality.</a:t>
             </a:r>
           </a:p>
-          <a:p/>
-          <a:p>
-            <a:r>
+          <a:p>
+            <a:pPr>
+              <a:spcAft>
+                <a:spcPts val="600"/>
+              </a:spcAft>
+            </a:pPr>
+          </a:p>
+          <a:p>
+            <a:pPr>
+              <a:spcAft>
+                <a:spcPts val="600"/>
+              </a:spcAft>
+            </a:pPr>
+            <a:r>
+              <a:rPr sz="1400"/>
               <a:t>Semantics in front, hardware scheduling behind. They compose.</a:t>
             </a:r>
           </a:p>
-          <a:p/>
-          <a:p>
-            <a:r>
+          <a:p>
+            <a:pPr>
+              <a:spcAft>
+                <a:spcPts val="600"/>
+              </a:spcAft>
+            </a:pPr>
+          </a:p>
+          <a:p>
+            <a:pPr>
+              <a:spcAft>
+                <a:spcPts val="600"/>
+              </a:spcAft>
+            </a:pPr>
+            <a:r>
+              <a:rPr sz="1400"/>
               <a:t>There's a nice detail in the caches too — they don't overlap. Ours skips a whole request when the same question has been asked before. llm-d's prefix cache skips recomputing the shared front of every request. Different savings, same stack.</a:t>
             </a:r>
           </a:p>
-          <a:p/>
-          <a:p>
-            <a:r>
+          <a:p>
+            <a:pPr>
+              <a:spcAft>
+                <a:spcPts val="600"/>
+              </a:spcAft>
+            </a:pPr>
+          </a:p>
+          <a:p>
+            <a:pPr>
+              <a:spcAft>
+                <a:spcPts val="600"/>
+              </a:spcAft>
+            </a:pPr>
+            <a:r>
+              <a:rPr sz="1400"/>
               <a:t>Right — let me show you this actually running.</a:t>
             </a:r>
           </a:p>
@@ -1437,31 +1929,85 @@
           <a:bodyPr/>
           <a:lstStyle/>
           <a:p>
-            <a:r>
+            <a:pPr>
+              <a:spcAft>
+                <a:spcPts val="600"/>
+              </a:spcAft>
+            </a:pPr>
+            <a:r>
+              <a:rPr sz="1400"/>
               <a:t>Everything you're about to see is live on an OpenShift cluster. Nothing here is recorded.</a:t>
             </a:r>
           </a:p>
-          <a:p/>
-          <a:p>
-            <a:r>
+          <a:p>
+            <a:pPr>
+              <a:spcAft>
+                <a:spcPts val="600"/>
+              </a:spcAft>
+            </a:pPr>
+          </a:p>
+          <a:p>
+            <a:pPr>
+              <a:spcAft>
+                <a:spcPts val="600"/>
+              </a:spcAft>
+            </a:pPr>
+            <a:r>
+              <a:rPr sz="1400"/>
               <a:t>One endpoint at the front: an OpenShift route into Envoy, with the router attached as an external processor in the same pod. The client sends model "auto" and nothing else.</a:t>
             </a:r>
           </a:p>
-          <a:p/>
-          <a:p>
-            <a:r>
+          <a:p>
+            <a:pPr>
+              <a:spcAft>
+                <a:spcPts val="600"/>
+              </a:spcAft>
+            </a:pPr>
+          </a:p>
+          <a:p>
+            <a:pPr>
+              <a:spcAft>
+                <a:spcPts val="600"/>
+              </a:spcAft>
+            </a:pPr>
+            <a:r>
+              <a:rPr sz="1400"/>
               <a:t>Behind it, two models on KServe. Qwen 2.5 7B on an L40S for the hard, urgent and quantitative work. Phi-3-mini on a T4 for everything else.</a:t>
             </a:r>
           </a:p>
-          <a:p/>
-          <a:p>
-            <a:r>
+          <a:p>
+            <a:pPr>
+              <a:spcAft>
+                <a:spcPts val="600"/>
+              </a:spcAft>
+            </a:pPr>
+          </a:p>
+          <a:p>
+            <a:pPr>
+              <a:spcAft>
+                <a:spcPts val="600"/>
+              </a:spcAft>
+            </a:pPr>
+            <a:r>
+              <a:rPr sz="1400"/>
               <a:t>And the part I'd draw your attention to: the five classifier processes and the router itself share one container on a plain worker node with no GPU at all. The accelerators only ever generate tokens. The intelligence layer never competes with the serving layer for hardware.</a:t>
             </a:r>
           </a:p>
-          <a:p/>
-          <a:p>
-            <a:r>
+          <a:p>
+            <a:pPr>
+              <a:spcAft>
+                <a:spcPts val="600"/>
+              </a:spcAft>
+            </a:pPr>
+          </a:p>
+          <a:p>
+            <a:pPr>
+              <a:spcAft>
+                <a:spcPts val="600"/>
+              </a:spcAft>
+            </a:pPr>
+            <a:r>
+              <a:rPr sz="1400"/>
               <a:t>Fifteen use cases, about ten minutes. Let's go.</a:t>
             </a:r>
           </a:p>
@@ -1531,25 +2077,67 @@
           <a:bodyPr/>
           <a:lstStyle/>
           <a:p>
-            <a:r>
+            <a:pPr>
+              <a:spcAft>
+                <a:spcPts val="600"/>
+              </a:spcAft>
+            </a:pPr>
+            <a:r>
+              <a:rPr sz="1400"/>
               <a:t>A couple of years ago the question was simple: which model is best? That question is basically dead now, because your estate fragments along four axes at the same time.</a:t>
             </a:r>
           </a:p>
-          <a:p/>
-          <a:p>
-            <a:r>
+          <a:p>
+            <a:pPr>
+              <a:spcAft>
+                <a:spcPts val="600"/>
+              </a:spcAft>
+            </a:pPr>
+          </a:p>
+          <a:p>
+            <a:pPr>
+              <a:spcAft>
+                <a:spcPts val="600"/>
+              </a:spcAft>
+            </a:pPr>
+            <a:r>
+              <a:rPr sz="1400"/>
               <a:t>First, the models themselves — large, small, hybrid reasoning, specialists, open and closed. Second, what they run on: CPU, GPU, NPU, mixed fleets, all with different cost and energy profiles. Third, location — cloud, your data centre, the edge. And for a lot of you that third one is a compliance question long before it's a performance question.</a:t>
             </a:r>
           </a:p>
-          <a:p/>
-          <a:p>
-            <a:r>
+          <a:p>
+            <a:pPr>
+              <a:spcAft>
+                <a:spcPts val="600"/>
+              </a:spcAft>
+            </a:pPr>
+          </a:p>
+          <a:p>
+            <a:pPr>
+              <a:spcAft>
+                <a:spcPts val="600"/>
+              </a:spcAft>
+            </a:pPr>
+            <a:r>
+              <a:rPr sz="1400"/>
               <a:t>And fourth, preference. Quality, latency, cost, privacy. Those conflict with each other, and the right trade-off is different per request — not per application.</a:t>
             </a:r>
           </a:p>
-          <a:p/>
-          <a:p>
-            <a:r>
+          <a:p>
+            <a:pPr>
+              <a:spcAft>
+                <a:spcPts val="600"/>
+              </a:spcAft>
+            </a:pPr>
+          </a:p>
+          <a:p>
+            <a:pPr>
+              <a:spcAft>
+                <a:spcPts val="600"/>
+              </a:spcAft>
+            </a:pPr>
+            <a:r>
+              <a:rPr sz="1400"/>
               <a:t>Now multiply those together. That's the space every single request has to be placed into. And today, without a routing layer, every application you own is navigating all four of those on its own, in code, separately.</a:t>
             </a:r>
           </a:p>
@@ -1619,43 +2207,121 @@
           <a:bodyPr/>
           <a:lstStyle/>
           <a:p>
-            <a:r>
+            <a:pPr>
+              <a:spcAft>
+                <a:spcPts val="600"/>
+              </a:spcAft>
+            </a:pPr>
+            <a:r>
+              <a:rPr sz="1400"/>
               <a:t>[Map slide — don't read it. Switch to the console.]</a:t>
             </a:r>
           </a:p>
-          <a:p/>
-          <a:p>
-            <a:r>
+          <a:p>
+            <a:pPr>
+              <a:spcAft>
+                <a:spcPts val="600"/>
+              </a:spcAft>
+            </a:pPr>
+          </a:p>
+          <a:p>
+            <a:pPr>
+              <a:spcAft>
+                <a:spcPts val="600"/>
+              </a:spcAft>
+            </a:pPr>
+            <a:r>
+              <a:rPr sz="1400"/>
               <a:t>Run order: 1, 3, 4, 5 — then 7 — then 8, 9 — then 13, 14 — then 11.</a:t>
             </a:r>
           </a:p>
-          <a:p/>
-          <a:p>
-            <a:r>
+          <a:p>
+            <a:pPr>
+              <a:spcAft>
+                <a:spcPts val="600"/>
+              </a:spcAft>
+            </a:pPr>
+          </a:p>
+          <a:p>
+            <a:pPr>
+              <a:spcAft>
+                <a:spcPts val="600"/>
+              </a:spcAft>
+            </a:pPr>
+            <a:r>
+              <a:rPr sz="1400"/>
               <a:t>Three pairs do the real work.</a:t>
             </a:r>
           </a:p>
-          <a:p/>
-          <a:p>
-            <a:r>
+          <a:p>
+            <a:pPr>
+              <a:spcAft>
+                <a:spcPts val="600"/>
+              </a:spcAft>
+            </a:pPr>
+          </a:p>
+          <a:p>
+            <a:pPr>
+              <a:spcAft>
+                <a:spcPts val="600"/>
+              </a:spcAft>
+            </a:pPr>
+            <a:r>
+              <a:rPr sz="1400"/>
               <a:t>4 and 5 back to back: same topic, opposite routing, because it's grading difficulty and not subject. Say that out loud — "it's still Python, and it still goes to the small model".</a:t>
             </a:r>
           </a:p>
-          <a:p/>
-          <a:p>
-            <a:r>
+          <a:p>
+            <a:pPr>
+              <a:spcAft>
+                <a:spcPts val="600"/>
+              </a:spcAft>
+            </a:pPr>
+          </a:p>
+          <a:p>
+            <a:pPr>
+              <a:spcAft>
+                <a:spcPts val="600"/>
+              </a:spcAft>
+            </a:pPr>
+            <a:r>
+              <a:rPr sz="1400"/>
               <a:t>8 and 9 back to back: the second one has no banned phrase anywhere in it. That's the entire argument for having a classifier as well as a deny-list.</a:t>
             </a:r>
           </a:p>
-          <a:p/>
-          <a:p>
-            <a:r>
+          <a:p>
+            <a:pPr>
+              <a:spcAft>
+                <a:spcPts val="600"/>
+              </a:spcAft>
+            </a:pPr>
+          </a:p>
+          <a:p>
+            <a:pPr>
+              <a:spcAft>
+                <a:spcPts val="600"/>
+              </a:spcAft>
+            </a:pPr>
+            <a:r>
+              <a:rPr sz="1400"/>
               <a:t>13 and 14: the cache working, then the cache correctly refusing a question that's two words different.</a:t>
             </a:r>
           </a:p>
-          <a:p/>
-          <a:p>
-            <a:r>
+          <a:p>
+            <a:pPr>
+              <a:spcAft>
+                <a:spcPts val="600"/>
+              </a:spcAft>
+            </a:pPr>
+          </a:p>
+          <a:p>
+            <a:pPr>
+              <a:spcAft>
+                <a:spcPts val="600"/>
+              </a:spcAft>
+            </a:pPr>
+            <a:r>
+              <a:rPr sz="1400"/>
               <a:t>Every prompt box is editable — if there's time, edit one live. It's the most convincing thing you can do.</a:t>
             </a:r>
           </a:p>
@@ -1725,25 +2391,67 @@
           <a:bodyPr/>
           <a:lstStyle/>
           <a:p>
-            <a:r>
+            <a:pPr>
+              <a:spcAft>
+                <a:spcPts val="600"/>
+              </a:spcAft>
+            </a:pPr>
+            <a:r>
+              <a:rPr sz="1400"/>
               <a:t>[Press c first so the counters start at zero.]</a:t>
             </a:r>
           </a:p>
-          <a:p/>
-          <a:p>
-            <a:r>
+          <a:p>
+            <a:pPr>
+              <a:spcAft>
+                <a:spcPts val="600"/>
+              </a:spcAft>
+            </a:pPr>
+          </a:p>
+          <a:p>
+            <a:pPr>
+              <a:spcAft>
+                <a:spcPts val="600"/>
+              </a:spcAft>
+            </a:pPr>
+            <a:r>
+              <a:rPr sz="1400"/>
               <a:t>If you finish early: take a prompt from the audience and run it. You don't control the answer, which is the point — and the failure mode is benign. It either goes to one of two models, or a guardrail stops it.</a:t>
             </a:r>
           </a:p>
-          <a:p/>
-          <a:p>
-            <a:r>
+          <a:p>
+            <a:pPr>
+              <a:spcAft>
+                <a:spcPts val="600"/>
+              </a:spcAft>
+            </a:pPr>
+          </a:p>
+          <a:p>
+            <a:pPr>
+              <a:spcAft>
+                <a:spcPts val="600"/>
+              </a:spcAft>
+            </a:pPr>
+            <a:r>
+              <a:rPr sz="1400"/>
               <a:t>Closing line: "The entire routing policy is one readable YAML file in that repo. All fifteen cases are documented with the measurements behind them. And it took me about an afternoon to get wrong in ten different ways, all of which are written up in the troubleshooting guide."</a:t>
             </a:r>
           </a:p>
-          <a:p/>
-          <a:p>
-            <a:r>
+          <a:p>
+            <a:pPr>
+              <a:spcAft>
+                <a:spcPts val="600"/>
+              </a:spcAft>
+            </a:pPr>
+          </a:p>
+          <a:p>
+            <a:pPr>
+              <a:spcAft>
+                <a:spcPts val="600"/>
+              </a:spcAft>
+            </a:pPr>
+            <a:r>
+              <a:rPr sz="1400"/>
               <a:t>Then take questions.</a:t>
             </a:r>
           </a:p>
@@ -1813,31 +2521,85 @@
           <a:bodyPr/>
           <a:lstStyle/>
           <a:p>
-            <a:r>
+            <a:pPr>
+              <a:spcAft>
+                <a:spcPts val="600"/>
+              </a:spcAft>
+            </a:pPr>
+            <a:r>
+              <a:rPr sz="1400"/>
               <a:t>Here's what that costs in practice.</a:t>
             </a:r>
           </a:p>
-          <a:p/>
-          <a:p>
-            <a:r>
+          <a:p>
+            <a:pPr>
+              <a:spcAft>
+                <a:spcPts val="600"/>
+              </a:spcAft>
+            </a:pPr>
+          </a:p>
+          <a:p>
+            <a:pPr>
+              <a:spcAft>
+                <a:spcPts val="600"/>
+              </a:spcAft>
+            </a:pPr>
+            <a:r>
+              <a:rPr sz="1400"/>
               <a:t>Uber put five thousand engineers onto token-metered coding assistants. Eighty-four percent adoption — which, if you've ever tried to roll out a developer tool, is a spectacular success story. Right up until April. Month four of twelve, and the entire year's AI budget was gone.</a:t>
             </a:r>
           </a:p>
-          <a:p/>
-          <a:p>
-            <a:r>
+          <a:p>
+            <a:pPr>
+              <a:spcAft>
+                <a:spcPts val="600"/>
+              </a:spcAft>
+            </a:pPr>
+          </a:p>
+          <a:p>
+            <a:pPr>
+              <a:spcAft>
+                <a:spcPts val="600"/>
+              </a:spcAft>
+            </a:pPr>
+            <a:r>
+              <a:rPr sz="1400"/>
               <a:t>Their CTO: "I'm back to the drawing board — the budget I thought I would need is blown away already."</a:t>
             </a:r>
           </a:p>
-          <a:p/>
-          <a:p>
-            <a:r>
+          <a:p>
+            <a:pPr>
+              <a:spcAft>
+                <a:spcPts val="600"/>
+              </a:spcAft>
+            </a:pPr>
+          </a:p>
+          <a:p>
+            <a:pPr>
+              <a:spcAft>
+                <a:spcPts val="600"/>
+              </a:spcAft>
+            </a:pPr>
+            <a:r>
+              <a:rPr sz="1400"/>
               <a:t>I want to be careful here, because the easy reading is that somebody was careless. That's not it. Token-metered consumption with no routing layer has no natural ceiling. And the better your adoption, the faster you hit it. Success is what breaks the budget.</a:t>
             </a:r>
           </a:p>
-          <a:p/>
-          <a:p>
-            <a:r>
+          <a:p>
+            <a:pPr>
+              <a:spcAft>
+                <a:spcPts val="600"/>
+              </a:spcAft>
+            </a:pPr>
+          </a:p>
+          <a:p>
+            <a:pPr>
+              <a:spcAft>
+                <a:spcPts val="600"/>
+              </a:spcAft>
+            </a:pPr>
+            <a:r>
+              <a:rPr sz="1400"/>
               <a:t>This is a published case study, not my data — but I suspect some of you recognise the shape of it.</a:t>
             </a:r>
           </a:p>
@@ -1907,37 +2669,103 @@
           <a:bodyPr/>
           <a:lstStyle/>
           <a:p>
-            <a:r>
+            <a:pPr>
+              <a:spcAft>
+                <a:spcPts val="600"/>
+              </a:spcAft>
+            </a:pPr>
+            <a:r>
+              <a:rPr sz="1400"/>
               <a:t>If you pull on that, you find four problems that look different and are actually the same bug.</a:t>
             </a:r>
           </a:p>
-          <a:p/>
-          <a:p>
-            <a:r>
+          <a:p>
+            <a:pPr>
+              <a:spcAft>
+                <a:spcPts val="600"/>
+              </a:spcAft>
+            </a:pPr>
+          </a:p>
+          <a:p>
+            <a:pPr>
+              <a:spcAft>
+                <a:spcPts val="600"/>
+              </a:spcAft>
+            </a:pPr>
+            <a:r>
+              <a:rPr sz="1400"/>
               <a:t>Unnecessary spend: a one-line question and a distributed-systems design problem cost exactly the same, because both of them named the same model.</a:t>
             </a:r>
           </a:p>
-          <a:p/>
-          <a:p>
-            <a:r>
+          <a:p>
+            <a:pPr>
+              <a:spcAft>
+                <a:spcPts val="600"/>
+              </a:spcAft>
+            </a:pPr>
+          </a:p>
+          <a:p>
+            <a:pPr>
+              <a:spcAft>
+                <a:spcPts val="600"/>
+              </a:spcAft>
+            </a:pPr>
+            <a:r>
+              <a:rPr sz="1400"/>
               <a:t>Data sovereignty: personal data, financial data, medical data walks out of your data centre to reach a cloud model — because nothing inspected it on the way out.</a:t>
             </a:r>
           </a:p>
-          <a:p/>
-          <a:p>
-            <a:r>
+          <a:p>
+            <a:pPr>
+              <a:spcAft>
+                <a:spcPts val="600"/>
+              </a:spcAft>
+            </a:pPr>
+          </a:p>
+          <a:p>
+            <a:pPr>
+              <a:spcAft>
+                <a:spcPts val="600"/>
+              </a:spcAft>
+            </a:pPr>
+            <a:r>
+              <a:rPr sz="1400"/>
               <a:t>Safety: jailbreak attempts go straight through to inference, because there's nothing between the prompt and the model. And latency: trivial requests sit in a queue behind heavy reasoning work on the same backend.</a:t>
             </a:r>
           </a:p>
-          <a:p/>
-          <a:p>
-            <a:r>
+          <a:p>
+            <a:pPr>
+              <a:spcAft>
+                <a:spcPts val="600"/>
+              </a:spcAft>
+            </a:pPr>
+          </a:p>
+          <a:p>
+            <a:pPr>
+              <a:spcAft>
+                <a:spcPts val="600"/>
+              </a:spcAft>
+            </a:pPr>
+            <a:r>
+              <a:rPr sz="1400"/>
               <a:t>One root cause. Your inference pipeline is content-blind. A load balancer has no idea what's inside the request it's forwarding — it's balancing bytes.</a:t>
             </a:r>
           </a:p>
-          <a:p/>
-          <a:p>
-            <a:r>
+          <a:p>
+            <a:pPr>
+              <a:spcAft>
+                <a:spcPts val="600"/>
+              </a:spcAft>
+            </a:pPr>
+          </a:p>
+          <a:p>
+            <a:pPr>
+              <a:spcAft>
+                <a:spcPts val="600"/>
+              </a:spcAft>
+            </a:pPr>
+            <a:r>
+              <a:rPr sz="1400"/>
               <a:t>And that's the thing to hold on to: you cannot enforce a policy you cannot see. If you want any of those four fixed, something has to read the request.</a:t>
             </a:r>
           </a:p>
@@ -2007,25 +2835,67 @@
           <a:bodyPr/>
           <a:lstStyle/>
           <a:p>
-            <a:r>
+            <a:pPr>
+              <a:spcAft>
+                <a:spcPts val="600"/>
+              </a:spcAft>
+            </a:pPr>
+            <a:r>
+              <a:rPr sz="1400"/>
               <a:t>So here's the idea, and it genuinely is one line.</a:t>
             </a:r>
           </a:p>
-          <a:p/>
-          <a:p>
-            <a:r>
+          <a:p>
+            <a:pPr>
+              <a:spcAft>
+                <a:spcPts val="600"/>
+              </a:spcAft>
+            </a:pPr>
+          </a:p>
+          <a:p>
+            <a:pPr>
+              <a:spcAft>
+                <a:spcPts val="600"/>
+              </a:spcAft>
+            </a:pPr>
+            <a:r>
+              <a:rPr sz="1400"/>
               <a:t>Read intent, domain, complexity and risk from the prompt and its context. Then compose the right model, the right mode, the right supporting capabilities.</a:t>
             </a:r>
           </a:p>
-          <a:p/>
-          <a:p>
-            <a:r>
+          <a:p>
+            <a:pPr>
+              <a:spcAft>
+                <a:spcPts val="600"/>
+              </a:spcAft>
+            </a:pPr>
+          </a:p>
+          <a:p>
+            <a:pPr>
+              <a:spcAft>
+                <a:spcPts val="600"/>
+              </a:spcAft>
+            </a:pPr>
+            <a:r>
+              <a:rPr sz="1400"/>
               <a:t>The part that matters if you actually have to ship this: your clients don't change. They send model "auto" over the ordinary OpenAI-compatible API. No SDK, no new library in your request path, no rewrite. In the demo later, my client is literally curl and a static HTML page.</a:t>
             </a:r>
           </a:p>
-          <a:p/>
-          <a:p>
-            <a:r>
+          <a:p>
+            <a:pPr>
+              <a:spcAft>
+                <a:spcPts val="600"/>
+              </a:spcAft>
+            </a:pPr>
+          </a:p>
+          <a:p>
+            <a:pPr>
+              <a:spcAft>
+                <a:spcPts val="600"/>
+              </a:spcAft>
+            </a:pPr>
+            <a:r>
+              <a:rPr sz="1400"/>
               <a:t>And the architectural payoff is the last line there. Intelligence moves upstream. The decision happens once, at the gateway, instead of being copied into every service you own — which means there's one place to change the policy, and critically, one place to audit it.</a:t>
             </a:r>
           </a:p>
@@ -2095,25 +2965,67 @@
           <a:bodyPr/>
           <a:lstStyle/>
           <a:p>
-            <a:r>
+            <a:pPr>
+              <a:spcAft>
+                <a:spcPts val="600"/>
+              </a:spcAft>
+            </a:pPr>
+            <a:r>
+              <a:rPr sz="1400"/>
               <a:t>Quick detour, because these two get conflated constantly and they're not even the same layer of the stack.</a:t>
             </a:r>
           </a:p>
-          <a:p/>
-          <a:p>
-            <a:r>
+          <a:p>
+            <a:pPr>
+              <a:spcAft>
+                <a:spcPts val="600"/>
+              </a:spcAft>
+            </a:pPr>
+          </a:p>
+          <a:p>
+            <a:pPr>
+              <a:spcAft>
+                <a:spcPts val="600"/>
+              </a:spcAft>
+            </a:pPr>
+            <a:r>
+              <a:rPr sz="1400"/>
               <a:t>Mixture-of-Experts is an architecture pattern inside one model. Sparse expert activation across layers. Somebody else chose it at training time, and you cannot inspect or change that routing — it's baked into the weights.</a:t>
             </a:r>
           </a:p>
-          <a:p/>
-          <a:p>
-            <a:r>
+          <a:p>
+            <a:pPr>
+              <a:spcAft>
+                <a:spcPts val="600"/>
+              </a:spcAft>
+            </a:pPr>
+          </a:p>
+          <a:p>
+            <a:pPr>
+              <a:spcAft>
+                <a:spcPts val="600"/>
+              </a:spcAft>
+            </a:pPr>
+            <a:r>
+              <a:rPr sz="1400"/>
               <a:t>Mixture-of-Models is a system pattern across independent models that differ in architecture, training data, capability, and the hardware they sit on. You choose it, in configuration, at request time.</a:t>
             </a:r>
           </a:p>
-          <a:p/>
-          <a:p>
-            <a:r>
+          <a:p>
+            <a:pPr>
+              <a:spcAft>
+                <a:spcPts val="600"/>
+              </a:spcAft>
+            </a:pPr>
+          </a:p>
+          <a:p>
+            <a:pPr>
+              <a:spcAft>
+                <a:spcPts val="600"/>
+              </a:spcAft>
+            </a:pPr>
+            <a:r>
+              <a:rPr sz="1400"/>
               <a:t>If you take one slide away from today, take this one. MoE is someone else's decision baked into weights. MoM is your decision, in your config, and you can change it this afternoon.</a:t>
             </a:r>
           </a:p>
@@ -2183,31 +3095,85 @@
           <a:bodyPr/>
           <a:lstStyle/>
           <a:p>
-            <a:r>
+            <a:pPr>
+              <a:spcAft>
+                <a:spcPts val="600"/>
+              </a:spcAft>
+            </a:pPr>
+            <a:r>
+              <a:rPr sz="1400"/>
               <a:t>Before I go further — where does this sit relative to what you already run?</a:t>
             </a:r>
           </a:p>
-          <a:p/>
-          <a:p>
-            <a:r>
+          <a:p>
+            <a:pPr>
+              <a:spcAft>
+                <a:spcPts val="600"/>
+              </a:spcAft>
+            </a:pPr>
+          </a:p>
+          <a:p>
+            <a:pPr>
+              <a:spcAft>
+                <a:spcPts val="600"/>
+              </a:spcAft>
+            </a:pPr>
+            <a:r>
+              <a:rPr sz="1400"/>
               <a:t>Three layers, one request path. The semantic router picks what logical model should handle this request, based on intent, complexity, privacy, modality. That happens at the gateway.</a:t>
             </a:r>
           </a:p>
-          <a:p/>
-          <a:p>
-            <a:r>
+          <a:p>
+            <a:pPr>
+              <a:spcAft>
+                <a:spcPts val="600"/>
+              </a:spcAft>
+            </a:pPr>
+          </a:p>
+          <a:p>
+            <a:pPr>
+              <a:spcAft>
+                <a:spcPts val="600"/>
+              </a:spcAft>
+            </a:pPr>
+            <a:r>
+              <a:rPr sz="1400"/>
               <a:t>Your serving layer — llm-d, the vLLM Production Stack, AIBrix, Dynamo — picks which replica runs it, based on load, queue depth, KV-cache locality.</a:t>
             </a:r>
           </a:p>
-          <a:p/>
-          <a:p>
-            <a:r>
+          <a:p>
+            <a:pPr>
+              <a:spcAft>
+                <a:spcPts val="600"/>
+              </a:spcAft>
+            </a:pPr>
+          </a:p>
+          <a:p>
+            <a:pPr>
+              <a:spcAft>
+                <a:spcPts val="600"/>
+              </a:spcAft>
+            </a:pPr>
+            <a:r>
+              <a:rPr sz="1400"/>
               <a:t>And then the backend actually generates the tokens, on whatever accelerator and in whatever location the policy allowed.</a:t>
             </a:r>
           </a:p>
-          <a:p/>
-          <a:p>
-            <a:r>
+          <a:p>
+            <a:pPr>
+              <a:spcAft>
+                <a:spcPts val="600"/>
+              </a:spcAft>
+            </a:pPr>
+          </a:p>
+          <a:p>
+            <a:pPr>
+              <a:spcAft>
+                <a:spcPts val="600"/>
+              </a:spcAft>
+            </a:pPr>
+            <a:r>
+              <a:rPr sz="1400"/>
               <a:t>So if you're already running one of those serving stacks: this goes in front of it, not instead of it. I'll come back to the llm-d relationship specifically at the end.</a:t>
             </a:r>
           </a:p>
@@ -2277,25 +3243,67 @@
           <a:bodyPr/>
           <a:lstStyle/>
           <a:p>
-            <a:r>
+            <a:pPr>
+              <a:spcAft>
+                <a:spcPts val="600"/>
+              </a:spcAft>
+            </a:pPr>
+            <a:r>
+              <a:rPr sz="1400"/>
               <a:t>Mechanically, it's an Envoy external processor. It is not a library sitting in your request path.</a:t>
             </a:r>
           </a:p>
-          <a:p/>
-          <a:p>
-            <a:r>
+          <a:p>
+            <a:pPr>
+              <a:spcAft>
+                <a:spcPts val="600"/>
+              </a:spcAft>
+            </a:pPr>
+          </a:p>
+          <a:p>
+            <a:pPr>
+              <a:spcAft>
+                <a:spcPts val="600"/>
+              </a:spcAft>
+            </a:pPr>
+            <a:r>
+              <a:rPr sz="1400"/>
               <a:t>Envoy receives the request and calls the router over gRPC. The router classifies the prompt and hands back a decision. Sometimes it answers immediately — if a guardrail fires, or if it's seen this question before, the request never reaches a model at all. Otherwise it sets a header naming the chosen model, and Envoy forwards it to that model's cluster.</a:t>
             </a:r>
           </a:p>
-          <a:p/>
-          <a:p>
-            <a:r>
+          <a:p>
+            <a:pPr>
+              <a:spcAft>
+                <a:spcPts val="600"/>
+              </a:spcAft>
+            </a:pPr>
+          </a:p>
+          <a:p>
+            <a:pPr>
+              <a:spcAft>
+                <a:spcPts val="600"/>
+              </a:spcAft>
+            </a:pPr>
+            <a:r>
+              <a:rPr sz="1400"/>
               <a:t>That "never reaches a model" point pays off twice in the demo. Blocked requests come back in under a second, and cache hits in about seven hundred milliseconds, because no GPU is involved at all.</a:t>
             </a:r>
           </a:p>
-          <a:p/>
-          <a:p>
-            <a:r>
+          <a:p>
+            <a:pPr>
+              <a:spcAft>
+                <a:spcPts val="600"/>
+              </a:spcAft>
+            </a:pPr>
+          </a:p>
+          <a:p>
+            <a:pPr>
+              <a:spcAft>
+                <a:spcPts val="600"/>
+              </a:spcAft>
+            </a:pPr>
+            <a:r>
+              <a:rPr sz="1400"/>
               <a:t>And it composes with what you have: standard Envoy, Kubernetes Gateway API, Istio. OpenAI and Anthropic compatible on the front door.</a:t>
             </a:r>
           </a:p>
@@ -2365,19 +3373,49 @@
           <a:bodyPr/>
           <a:lstStyle/>
           <a:p>
-            <a:r>
+            <a:pPr>
+              <a:spcAft>
+                <a:spcPts val="600"/>
+              </a:spcAft>
+            </a:pPr>
+            <a:r>
+              <a:rPr sz="1400"/>
               <a:t>Inside the router there are five stages, and each one has exactly one job. That separation is what makes the policy readable — and more importantly, auditable.</a:t>
             </a:r>
           </a:p>
-          <a:p/>
-          <a:p>
-            <a:r>
+          <a:p>
+            <a:pPr>
+              <a:spcAft>
+                <a:spcPts val="600"/>
+              </a:spcAft>
+            </a:pPr>
+          </a:p>
+          <a:p>
+            <a:pPr>
+              <a:spcAft>
+                <a:spcPts val="600"/>
+              </a:spcAft>
+            </a:pPr>
+            <a:r>
+              <a:rPr sz="1400"/>
               <a:t>Signals extract facts from the request. Projections combine those facts into something reusable. Decisions apply your policy. Algorithms select a model, or coordinate several. And model pools execute.</a:t>
             </a:r>
           </a:p>
-          <a:p/>
-          <a:p>
-            <a:r>
+          <a:p>
+            <a:pPr>
+              <a:spcAft>
+                <a:spcPts val="600"/>
+              </a:spcAft>
+            </a:pPr>
+          </a:p>
+          <a:p>
+            <a:pPr>
+              <a:spcAft>
+                <a:spcPts val="600"/>
+              </a:spcAft>
+            </a:pPr>
+            <a:r>
+              <a:rPr sz="1400"/>
               <a:t>I'm going to spend the next few minutes on three of these. And I'd flag stages two and four in particular — projections and algorithms — because those are the two that most demos skip entirely, and they're where this stops being a glorified if-statement.</a:t>
             </a:r>
           </a:p>

</xml_diff>